<commit_message>
v2.16 (John's word, 2 October): PROAPT, the why behind each step (S7-8). Slide 10's speaker notes gain a WHY line, one reason per step, with the deck and the Leader Notes handout in step and the slide face unchanged; new one-page leader page "PROAPT — What Each Step Is For" (md record in leader-pages/; Word + PDF in Planning) on the order: data before interpretation, what the text says before what it means; changelog v2.16
Co-Authored-By: Claude Opus 5.5 <noreply@anthropic.com>
</commit_message>
<xml_diff>
--- a/_implementation-notes/evening-series/FotH Evening Session 7-8 Combined Slides DRAFT v1.pptx
+++ b/_implementation-notes/evening-series/FotH Evening Session 7-8 Combined Slides DRAFT v1.pptx
@@ -1461,6 +1461,12 @@
               <a:t>CUES: If an Apply goes vague or grand, push gently for one specific concrete application.</a:t>
             </a:r>
           </a:p>
+          <a:p>
+            <a:r>
+              <a:rPr lang="en-US" sz="1200"/>
+              <a:t>WHY: the order protects the hearing — what the text says before what it means. 1. PRAY — we come to hear, not to extract; the Word is His. 2. READ — let it land whole before taking it apart. 3. OBSERVE, the data — the ground: what the page actually says, checkable by anyone; skipping it is where most misreadings start. OBSERVE, the interpretation — what it meant in its own world before it means anything in ours. 4. APPLY — where reading becomes hearing: one specific thing, for me, not for someone else. 5. PRAY AGAIN — hearing becomes a response; obedience starts here. 6. TELL — spoken hearing stays, and someone else hears what you heard. Full page: “PROAPT — What Each Step Is For” (Planning).</a:t>
+            </a:r>
+          </a:p>
         </p:txBody>
       </p:sp>
     </p:spTree>

</xml_diff>

<commit_message>
v2.26 (John's review, 8 October): Sessions 7-8 — pairs always (small-room circle option and parent-pairing bullet removed), one timekeeper with time targets (switch 8:02, Tell 8:13, back 8:19), the Pair Card (P12 on paper), day boxes on the daily-PROAPT homework (sheet still one page; P16 re-rendered), blessings spoken to the person not read off the screen (P18); sync tool files Pair/Breakout Cards
Co-Authored-By: Claude Opus 5.5 <noreply@anthropic.com>
</commit_message>
<xml_diff>
--- a/_implementation-notes/evening-series/FotH Evening Session 7-8 Combined Slides DRAFT v1.pptx
+++ b/_implementation-notes/evening-series/FotH Evening Session 7-8 Combined Slides DRAFT v1.pptx
@@ -1131,7 +1131,7 @@
           </a:p>
           <a:p>
             <a:r>
-              <a:t>CUES: Passage cards for both passages at each seat; the journal Week 7 pages carry the daily template.</a:t>
+              <a:t>CUES: Passage cards for both passages at each seat; the Pair Card printed, one per pair and a spare; the journal Week 7 pages carry the daily template.</a:t>
             </a:r>
           </a:p>
         </p:txBody>
@@ -1510,20 +1510,17 @@
           <a:lstStyle/>
           <a:p>
             <a:r>
-              <a:rPr lang="en-US" sz="1200"/>
               <a:t>S7 · 7:49–7:50 · LEAD: CONTENT PRESENTER · TRANSITION</a:t>
             </a:r>
           </a:p>
           <a:p>
             <a:r>
-              <a:rPr lang="en-US" sz="1200"/>
-              <a:t>BEATS: 1. Explain the pair shape: parent with your own teen by default; one Reader, one Listener; switch at twelve minutes. 2. Name it: pairing inside your own family is the design working, not the consolation prize. 3. Pray and send.</a:t>
-            </a:r>
-          </a:p>
-          <a:p>
-            <a:r>
-              <a:rPr lang="en-US" sz="1200"/>
-              <a:t>CUES: Lead Companions settle odd numbers across families. If the room is about ten or fewer, skip the pairing — one circle, pair up in place.</a:t>
+              <a:t>BEATS: 1. Explain the pair shape: parent with your own teen by default; one Reader, one Listener; switch at twelve minutes. 2. Name one timekeeper before anyone moves — the container holder by default, or anyone the leaders pick — who calls the switch at 8:02, the Tell at 8:13, and back in the circle at 8:19. 3. Hand each pair a Pair Card. 4. Pray and send.</a:t>
+            </a:r>
+          </a:p>
+          <a:p>
+            <a:r>
+              <a:t>CUES: Lead Companions settle odd numbers across families. Pairs always, even in a small room: the practice is one Reader and one Listener, and a circle cannot give that.</a:t>
             </a:r>
           </a:p>
         </p:txBody>
@@ -1574,7 +1571,17 @@
           </a:p>
           <a:p>
             <a:r>
+              <a:t>TIME TARGETS (the timekeeper calls them): pass one 7:50–8:02; switch at 8:02; pass two 8:02–8:13; the Tell, still in the pair, 8:13–8:19; back in the circle at 8:19 for the merge. If the room is running late, keep the two passes equal and shorten both rather than drop the second.</a:t>
+            </a:r>
+          </a:p>
+          <a:p>
+            <a:r>
               <a:t>BEATS: 1. First pass 12 min: Reader leads the six steps, Listener works alongside without interrupting; Reader's Tell goes to the Listener, one sentence. 2. Switch roles; second pass 12 min, same or new passage. 3. Companions float: stuck on Observe — 'one word or phrase that caught you'; stuck on Apply — 'one specific situation right now'; rushing — 'the Spirit isn't in a hurry'; finished early — another passage, get reps.</a:t>
+            </a:r>
+          </a:p>
+          <a:p>
+            <a:r>
+              <a:t>PRINT: the Pair Card (Leader Notes folder) carries this slide, the six steps, the passages, the times and the stuck-prompts, so each pair has it in hand away from the screen.</a:t>
             </a:r>
           </a:p>
           <a:p>
@@ -1807,19 +1814,16 @@
           <a:lstStyle/>
           <a:p>
             <a:r>
-              <a:rPr lang="en-US" sz="1200"/>
               <a:t>S7 · 8:28–8:30 · LEAD: CONTAINER HOLDER</a:t>
             </a:r>
           </a:p>
           <a:p>
             <a:r>
-              <a:rPr lang="en-US" sz="1200"/>
-              <a:t>BEATS: 1. Bridge the weeks: last week we named hard places, today we practiced hearing — both are real, both are how the Father walks us home; the place named last week is the place PROAPT will keep speaking into. 2. Aaronic blessing, hands up. 3. Send: 'PROAPT one passage tomorrow. See you evenings.'</a:t>
-            </a:r>
-          </a:p>
-          <a:p>
-            <a:r>
-              <a:rPr lang="en-US" sz="1200"/>
+              <a:t>BEATS: 1. Bridge the weeks: last week we named hard places, today we practiced hearing — both are real, both are how the Father walks us home; the place named last week is the place PROAPT will keep speaking into. 2. Blessings: turn away from the screen and face the person. Nothing to read — say what is in front of you for this person, specific and short. Then the Aaronic blessing, hands up. 3. Send: 'PROAPT one passage tomorrow. See you evenings.'</a:t>
+            </a:r>
+          </a:p>
+          <a:p>
+            <a:r>
               <a:t>CUES: Stay accessible after the close for anyone still carrying Week 6.</a:t>
             </a:r>
           </a:p>
@@ -5541,57 +5545,7 @@
                 </a:solidFill>
                 <a:latin typeface="Calibri"/>
               </a:rPr>
-              <a:t>“Pairing up with your own parent or your own teen is not the consolation-prize version — it is the design working.”</a:t>
-            </a:r>
-          </a:p>
-          <a:p>
-            <a:pPr marL="274320" indent="-274320">
-              <a:spcAft>
-                <a:spcPts val="900"/>
-              </a:spcAft>
-            </a:pPr>
-            <a:r>
-              <a:rPr sz="2400" b="1" i="0">
-                <a:solidFill>
-                  <a:srgbClr val="97BC62"/>
-                </a:solidFill>
-                <a:latin typeface="Calibri"/>
-              </a:rPr>
-              <a:t>•  </a:t>
-            </a:r>
-            <a:r>
-              <a:rPr sz="2400" b="0" i="0">
-                <a:solidFill>
-                  <a:srgbClr val="222B22"/>
-                </a:solidFill>
-                <a:latin typeface="Calibri"/>
-              </a:rPr>
               <a:t>Your Lead Companion settles the pairs and completes any odd numbers</a:t>
-            </a:r>
-          </a:p>
-          <a:p>
-            <a:pPr marL="274320" indent="-274320">
-              <a:spcAft>
-                <a:spcPts val="900"/>
-              </a:spcAft>
-            </a:pPr>
-            <a:r>
-              <a:rPr sz="2400" b="1" i="0">
-                <a:solidFill>
-                  <a:srgbClr val="97BC62"/>
-                </a:solidFill>
-                <a:latin typeface="Calibri"/>
-              </a:rPr>
-              <a:t>•  </a:t>
-            </a:r>
-            <a:r>
-              <a:rPr sz="2400" b="0" i="0">
-                <a:solidFill>
-                  <a:srgbClr val="222B22"/>
-                </a:solidFill>
-                <a:latin typeface="Calibri"/>
-              </a:rPr>
-              <a:t>Small room (about ten or fewer)? Stay as one circle and pair up in place</a:t>
             </a:r>
           </a:p>
         </p:txBody>
@@ -6828,15 +6782,15 @@
           <p:nvPr/>
         </p:nvPicPr>
         <p:blipFill>
-          <a:blip r:embed="rId2"/>
+          <a:blip r:embed="rId4"/>
           <a:stretch>
             <a:fillRect/>
           </a:stretch>
         </p:blipFill>
         <p:spPr>
           <a:xfrm>
-            <a:off x="2066004" y="1463040"/>
-            <a:ext cx="8059687" cy="4709160"/>
+            <a:off x="2622284" y="1463040"/>
+            <a:ext cx="6947127" cy="4709160"/>
           </a:xfrm>
           <a:prstGeom prst="rect">
             <a:avLst/>
@@ -7507,7 +7461,7 @@
                 </a:solidFill>
                 <a:latin typeface="Calibri"/>
               </a:rPr>
-              <a:t>Blessings — specific, witnessed, short</a:t>
+              <a:t>Blessings — eyes on the person, not the screen: say what is on your heart for them. Specific, witnessed, short</a:t>
             </a:r>
           </a:p>
           <a:p>

</xml_diff>

<commit_message>
v2.29 (John's planning lab, 11 October): Sessions 7-8 — fresh passages for pass one on the Pair Card; take-home: own journal with the handout as template, choose a paragraph, don't skip the Tell, the preparation sentence filled; the container holder keeps the clock (no separate timekeeper); planning lab rehearses delivery; Sessions 9-10 on Monday 26 October
Co-Authored-By: Claude Opus 5.5 <noreply@anthropic.com>
</commit_message>
<xml_diff>
--- a/_implementation-notes/evening-series/FotH Evening Session 7-8 Combined Slides DRAFT v1.pptx
+++ b/_implementation-notes/evening-series/FotH Evening Session 7-8 Combined Slides DRAFT v1.pptx
@@ -940,7 +940,7 @@
           </a:p>
           <a:p>
             <a:r>
-              <a:t>1. The four parts, in order: the homework practice, week one; the end-of-week-one check-in; the homework practice, week two; one sentence of preparation.</a:t>
+              <a:t>1. The four parts, in order: the homework practice, week one; the end-of-week-one check-in; the homework practice, week two; one sentence of preparation. Name the two new lines: choose a paragraph (one central thought), and don't skip the Tell.</a:t>
             </a:r>
           </a:p>
           <a:p>
@@ -1515,7 +1515,7 @@
           </a:p>
           <a:p>
             <a:r>
-              <a:t>BEATS: 1. Explain the pair shape: parent with your own teen by default; one Reader, one Listener; switch at twelve minutes. 2. Name one timekeeper before anyone moves — the container holder by default, or anyone the leaders pick — who calls the switch at 8:02, the Tell at 8:13, and back in the circle at 8:19. 3. Hand each pair a Pair Card. 4. Pray and send.</a:t>
+              <a:t>BEATS: 1. Explain the pair shape: parent with your own teen by default; one Reader, one Listener; switch at twelve minutes. 2. The container holder keeps the clock and calls the switch at 8:02, the Tell at 8:13, and back in the circle at 8:19. 3. Hand each pair a Pair Card. 4. Pray and send.</a:t>
             </a:r>
           </a:p>
           <a:p>
@@ -1571,12 +1571,12 @@
           </a:p>
           <a:p>
             <a:r>
-              <a:t>TIME TARGETS (the timekeeper calls them): pass one 7:50–8:02; switch at 8:02; pass two 8:02–8:13; the Tell, still in the pair, 8:13–8:19; back in the circle at 8:19 for the merge. If the room is running late, keep the two passes equal and shorten both rather than drop the second.</a:t>
-            </a:r>
-          </a:p>
-          <a:p>
-            <a:r>
-              <a:t>BEATS: 1. First pass 12 min: Reader leads the six steps, Listener works alongside without interrupting; Reader's Tell goes to the Listener, one sentence. 2. Switch roles; second pass 12 min, same or new passage. 3. Companions float: stuck on Observe — 'one word or phrase that caught you'; stuck on Apply — 'one specific situation right now'; rushing — 'the Spirit isn't in a hurry'; finished early — another passage, get reps.</a:t>
+              <a:t>TIME TARGETS (the container holder calls them): pass one 7:50–8:02; switch at 8:02; pass two 8:02–8:13; the Tell, still in the pair, 8:13–8:19; back in the circle at 8:19 for the merge. If the room is running late, keep the two passes equal and shorten both rather than drop the second.</a:t>
+            </a:r>
+          </a:p>
+          <a:p>
+            <a:r>
+              <a:t>BEATS: 1. First pass 12 min: Reader leads the six steps, Listener works alongside without interrupting; Reader's Tell goes to the Listener, one sentence. 2. Switch roles; second pass 12 min, same or new passage. For pass one, pairs may take a fresh passage instead of Mark 1:14–20 again: Luke 5:1–11, John 1:35–42, or Mark 10:46–52 (on the Pair Card). 3. Companions float: stuck on Observe — 'one word or phrase that caught you'; stuck on Apply — 'one specific situation right now'; rushing — 'the Spirit isn't in a hurry'; finished early — another passage, get reps.</a:t>
             </a:r>
           </a:p>
           <a:p>

</xml_diff>

<commit_message>
v2.34: journal lines in Evenings 4 and 6 point to your own journal (John's word); changelog
Co-Authored-By: Claude Opus 5.5 <noreply@anthropic.com>
</commit_message>
<xml_diff>
--- a/_implementation-notes/evening-series/FotH Evening Session 7-8 Combined Slides DRAFT v1.pptx
+++ b/_implementation-notes/evening-series/FotH Evening Session 7-8 Combined Slides DRAFT v1.pptx
@@ -1128,7 +1128,7 @@
           </a:p>
           <a:p>
             <a:r>
-              <a:t>CUES: Passage cards for both passages at each seat; the Pair Card printed, one per pair and a spare; the journal Week 7 pages carry the daily template.</a:t>
+              <a:t>CUES: Passage cards for both passages at each seat; the Pair Card printed, one per pair and a spare; your own journal, with the PROAPT page of the take-home as the daily template.</a:t>
             </a:r>
           </a:p>
         </p:txBody>
@@ -1677,7 +1677,7 @@
           </a:p>
           <a:p>
             <a:r>
-              <a:t>BEATS: 1. One word each — not what you heard (that is yours), but what the practice was like. 2. Introduce daily PROAPT: one short passage, five to ten minutes, every day — the journal Week 7 pages have the template. 3. Hold up H7.3: passage paths for teens and parents. 4. 'The chain only works if we work it.'</a:t>
+              <a:t>BEATS: 1. One word each — not what you heard (that is yours), but what the practice was like. 2. Introduce daily PROAPT: one short passage, five to ten minutes, every day — your own journal, with the PROAPT page of the take-home as the template. 3. Hold up H7.3: passage paths for teens and parents. 4. 'The chain only works if we work it.'</a:t>
             </a:r>
           </a:p>
           <a:p>
@@ -6306,7 +6306,7 @@
                 </a:solidFill>
                 <a:latin typeface="Calibri"/>
               </a:rPr>
-              <a:t>The journal Week 7 pages have a daily PROAPT template</a:t>
+              <a:t>Your own journal — the PROAPT page of the take-home is the template</a:t>
             </a:r>
           </a:p>
           <a:p>

</xml_diff>